<commit_message>
Update Categorical Data presentation file
</commit_message>
<xml_diff>
--- a/My Note and Practice/Text to Numerical Data Conversion/Categorical(Text to Numeric) data conversion-CTtN/Categorical Data.pptx
+++ b/My Note and Practice/Text to Numerical Data Conversion/Categorical(Text to Numeric) data conversion-CTtN/Categorical Data.pptx
@@ -16,7 +16,6 @@
     <p:sldId id="307" r:id="rId10"/>
     <p:sldId id="310" r:id="rId11"/>
     <p:sldId id="308" r:id="rId12"/>
-    <p:sldId id="309" r:id="rId13"/>
   </p:sldIdLst>
   <p:sldSz cx="12192000" cy="6858000"/>
   <p:notesSz cx="6858000" cy="9144000"/>
@@ -270,7 +269,7 @@
           <a:p>
             <a:fld id="{9470F815-C135-485A-BD08-28298AAD7E25}" type="datetimeFigureOut">
               <a:rPr lang="en-US" smtClean="0"/>
-              <a:t>11/8/2025</a:t>
+              <a:t>11/19/2025</a:t>
             </a:fld>
             <a:endParaRPr lang="en-US"/>
           </a:p>
@@ -468,7 +467,7 @@
           <a:p>
             <a:fld id="{9470F815-C135-485A-BD08-28298AAD7E25}" type="datetimeFigureOut">
               <a:rPr lang="en-US" smtClean="0"/>
-              <a:t>11/8/2025</a:t>
+              <a:t>11/19/2025</a:t>
             </a:fld>
             <a:endParaRPr lang="en-US"/>
           </a:p>
@@ -676,7 +675,7 @@
           <a:p>
             <a:fld id="{9470F815-C135-485A-BD08-28298AAD7E25}" type="datetimeFigureOut">
               <a:rPr lang="en-US" smtClean="0"/>
-              <a:t>11/8/2025</a:t>
+              <a:t>11/19/2025</a:t>
             </a:fld>
             <a:endParaRPr lang="en-US"/>
           </a:p>
@@ -874,7 +873,7 @@
           <a:p>
             <a:fld id="{9470F815-C135-485A-BD08-28298AAD7E25}" type="datetimeFigureOut">
               <a:rPr lang="en-US" smtClean="0"/>
-              <a:t>11/8/2025</a:t>
+              <a:t>11/19/2025</a:t>
             </a:fld>
             <a:endParaRPr lang="en-US"/>
           </a:p>
@@ -1149,7 +1148,7 @@
           <a:p>
             <a:fld id="{9470F815-C135-485A-BD08-28298AAD7E25}" type="datetimeFigureOut">
               <a:rPr lang="en-US" smtClean="0"/>
-              <a:t>11/8/2025</a:t>
+              <a:t>11/19/2025</a:t>
             </a:fld>
             <a:endParaRPr lang="en-US"/>
           </a:p>
@@ -1414,7 +1413,7 @@
           <a:p>
             <a:fld id="{9470F815-C135-485A-BD08-28298AAD7E25}" type="datetimeFigureOut">
               <a:rPr lang="en-US" smtClean="0"/>
-              <a:t>11/8/2025</a:t>
+              <a:t>11/19/2025</a:t>
             </a:fld>
             <a:endParaRPr lang="en-US"/>
           </a:p>
@@ -1826,7 +1825,7 @@
           <a:p>
             <a:fld id="{9470F815-C135-485A-BD08-28298AAD7E25}" type="datetimeFigureOut">
               <a:rPr lang="en-US" smtClean="0"/>
-              <a:t>11/8/2025</a:t>
+              <a:t>11/19/2025</a:t>
             </a:fld>
             <a:endParaRPr lang="en-US"/>
           </a:p>
@@ -1967,7 +1966,7 @@
           <a:p>
             <a:fld id="{9470F815-C135-485A-BD08-28298AAD7E25}" type="datetimeFigureOut">
               <a:rPr lang="en-US" smtClean="0"/>
-              <a:t>11/8/2025</a:t>
+              <a:t>11/19/2025</a:t>
             </a:fld>
             <a:endParaRPr lang="en-US"/>
           </a:p>
@@ -2080,7 +2079,7 @@
           <a:p>
             <a:fld id="{9470F815-C135-485A-BD08-28298AAD7E25}" type="datetimeFigureOut">
               <a:rPr lang="en-US" smtClean="0"/>
-              <a:t>11/8/2025</a:t>
+              <a:t>11/19/2025</a:t>
             </a:fld>
             <a:endParaRPr lang="en-US"/>
           </a:p>
@@ -2391,7 +2390,7 @@
           <a:p>
             <a:fld id="{9470F815-C135-485A-BD08-28298AAD7E25}" type="datetimeFigureOut">
               <a:rPr lang="en-US" smtClean="0"/>
-              <a:t>11/8/2025</a:t>
+              <a:t>11/19/2025</a:t>
             </a:fld>
             <a:endParaRPr lang="en-US"/>
           </a:p>
@@ -2679,7 +2678,7 @@
           <a:p>
             <a:fld id="{9470F815-C135-485A-BD08-28298AAD7E25}" type="datetimeFigureOut">
               <a:rPr lang="en-US" smtClean="0"/>
-              <a:t>11/8/2025</a:t>
+              <a:t>11/19/2025</a:t>
             </a:fld>
             <a:endParaRPr lang="en-US"/>
           </a:p>
@@ -2920,7 +2919,7 @@
           <a:p>
             <a:fld id="{9470F815-C135-485A-BD08-28298AAD7E25}" type="datetimeFigureOut">
               <a:rPr lang="en-US" smtClean="0"/>
-              <a:t>11/8/2025</a:t>
+              <a:t>11/19/2025</a:t>
             </a:fld>
             <a:endParaRPr lang="en-US"/>
           </a:p>
@@ -4170,123 +4169,6 @@
 </p:sld>
 </file>
 
-<file path=ppt/slides/slide12.xml><?xml version="1.0" encoding="utf-8"?>
-<p:sld xmlns:a="http://schemas.openxmlformats.org/drawingml/2006/main" xmlns:r="http://schemas.openxmlformats.org/officeDocument/2006/relationships" xmlns:p="http://schemas.openxmlformats.org/presentationml/2006/main">
-  <p:cSld>
-    <p:spTree>
-      <p:nvGrpSpPr>
-        <p:cNvPr id="1" name="">
-          <a:extLst>
-            <a:ext uri="{FF2B5EF4-FFF2-40B4-BE49-F238E27FC236}">
-              <a16:creationId xmlns:a16="http://schemas.microsoft.com/office/drawing/2014/main" id="{8CA822CF-61E7-D4A4-E048-D296A45421F7}"/>
-            </a:ext>
-          </a:extLst>
-        </p:cNvPr>
-        <p:cNvGrpSpPr/>
-        <p:nvPr/>
-      </p:nvGrpSpPr>
-      <p:grpSpPr>
-        <a:xfrm>
-          <a:off x="0" y="0"/>
-          <a:ext cx="0" cy="0"/>
-          <a:chOff x="0" y="0"/>
-          <a:chExt cx="0" cy="0"/>
-        </a:xfrm>
-      </p:grpSpPr>
-      <p:sp>
-        <p:nvSpPr>
-          <p:cNvPr id="2" name="Title 1">
-            <a:extLst>
-              <a:ext uri="{FF2B5EF4-FFF2-40B4-BE49-F238E27FC236}">
-                <a16:creationId xmlns:a16="http://schemas.microsoft.com/office/drawing/2014/main" id="{B0117384-56C5-24B5-624E-767F3168840B}"/>
-              </a:ext>
-            </a:extLst>
-          </p:cNvPr>
-          <p:cNvSpPr>
-            <a:spLocks noGrp="1"/>
-          </p:cNvSpPr>
-          <p:nvPr>
-            <p:ph type="title"/>
-          </p:nvPr>
-        </p:nvSpPr>
-        <p:spPr>
-          <a:xfrm>
-            <a:off x="838200" y="365125"/>
-            <a:ext cx="10515600" cy="640080"/>
-          </a:xfrm>
-        </p:spPr>
-        <p:txBody>
-          <a:bodyPr>
-            <a:normAutofit/>
-          </a:bodyPr>
-          <a:lstStyle/>
-          <a:p>
-            <a:pPr algn="ctr"/>
-            <a:r>
-              <a:rPr lang="en-US" sz="3600" dirty="0">
-                <a:latin typeface="Bebas Neue" panose="020B0606020202050201" pitchFamily="34" charset="0"/>
-              </a:rPr>
-              <a:t>T</a:t>
-            </a:r>
-            <a:endParaRPr lang="en-US" sz="3600" dirty="0"/>
-          </a:p>
-        </p:txBody>
-      </p:sp>
-      <p:sp>
-        <p:nvSpPr>
-          <p:cNvPr id="3" name="Content Placeholder 2">
-            <a:extLst>
-              <a:ext uri="{FF2B5EF4-FFF2-40B4-BE49-F238E27FC236}">
-                <a16:creationId xmlns:a16="http://schemas.microsoft.com/office/drawing/2014/main" id="{F56ACDEB-9BE6-9E8C-F3F3-47CC1816FE9C}"/>
-              </a:ext>
-            </a:extLst>
-          </p:cNvPr>
-          <p:cNvSpPr>
-            <a:spLocks noGrp="1"/>
-          </p:cNvSpPr>
-          <p:nvPr>
-            <p:ph idx="1"/>
-          </p:nvPr>
-        </p:nvSpPr>
-        <p:spPr>
-          <a:xfrm>
-            <a:off x="838200" y="1091381"/>
-            <a:ext cx="10515600" cy="5085582"/>
-          </a:xfrm>
-        </p:spPr>
-        <p:txBody>
-          <a:bodyPr>
-            <a:normAutofit/>
-          </a:bodyPr>
-          <a:lstStyle/>
-          <a:p>
-            <a:pPr marL="0" indent="0" algn="just">
-              <a:buNone/>
-            </a:pPr>
-            <a:r>
-              <a:rPr lang="en-US" sz="2400" dirty="0">
-                <a:latin typeface="Open Sans" pitchFamily="2" charset="0"/>
-                <a:ea typeface="Open Sans" pitchFamily="2" charset="0"/>
-                <a:cs typeface="Open Sans" pitchFamily="2" charset="0"/>
-              </a:rPr>
-              <a:t>H</a:t>
-            </a:r>
-          </a:p>
-        </p:txBody>
-      </p:sp>
-    </p:spTree>
-    <p:extLst>
-      <p:ext uri="{BB962C8B-B14F-4D97-AF65-F5344CB8AC3E}">
-        <p14:creationId xmlns:p14="http://schemas.microsoft.com/office/powerpoint/2010/main" val="1846840860"/>
-      </p:ext>
-    </p:extLst>
-  </p:cSld>
-  <p:clrMapOvr>
-    <a:masterClrMapping/>
-  </p:clrMapOvr>
-</p:sld>
-</file>
-
 <file path=ppt/slides/slide2.xml><?xml version="1.0" encoding="utf-8"?>
 <p:sld xmlns:a="http://schemas.openxmlformats.org/drawingml/2006/main" xmlns:r="http://schemas.openxmlformats.org/officeDocument/2006/relationships" xmlns:p="http://schemas.openxmlformats.org/presentationml/2006/main">
   <p:cSld>

</xml_diff>